<commit_message>
docs: personalize presentation and project guide with Team SankalpX and members
</commit_message>
<xml_diff>
--- a/GramSetu_SIH2026_Idea_Presentation.pptx
+++ b/GramSetu_SIH2026_Idea_Presentation.pptx
@@ -5811,8 +5811,8 @@
         </p:nvSpPr>
         <p:spPr>
           <a:xfrm>
-            <a:off x="731520" y="2103120"/>
-            <a:ext cx="10515600" cy="3840480"/>
+            <a:off x="731520" y="1874519"/>
+            <a:ext cx="10698480" cy="4297680"/>
           </a:xfrm>
           <a:prstGeom prst="rect">
             <a:avLst/>
@@ -5827,14 +5827,14 @@
           <a:p>
             <a:pPr>
               <a:spcBef>
-                <a:spcPts val="300"/>
+                <a:spcPts val="250"/>
               </a:spcBef>
               <a:spcAft>
-                <a:spcPts val="300"/>
+                <a:spcPts val="250"/>
               </a:spcAft>
             </a:pPr>
             <a:r>
-              <a:rPr sz="1400" b="1">
+              <a:rPr sz="1300" b="1">
                 <a:solidFill>
                   <a:srgbClr val="0A2540"/>
                 </a:solidFill>
@@ -5843,27 +5843,27 @@
               <a:t>Problem Statement ID –</a:t>
             </a:r>
             <a:r>
-              <a:rPr sz="1350" b="0">
+              <a:rPr sz="1250" b="0">
                 <a:solidFill>
                   <a:srgbClr val="334155"/>
                 </a:solidFill>
                 <a:latin typeface="Arial"/>
               </a:rPr>
-              <a:t> SIH2026 (Smart Governance / Citizen Empowerment)</a:t>
+              <a:t> SIH2026 (Smart Governance / Citizen Welfare)</a:t>
             </a:r>
             <a:endParaRPr lang="en-US" dirty="0"/>
           </a:p>
           <a:p>
             <a:pPr>
               <a:spcBef>
-                <a:spcPts val="300"/>
+                <a:spcPts val="250"/>
               </a:spcBef>
               <a:spcAft>
-                <a:spcPts val="300"/>
+                <a:spcPts val="250"/>
               </a:spcAft>
             </a:pPr>
             <a:r>
-              <a:rPr sz="1400" b="1">
+              <a:rPr sz="1300" b="1">
                 <a:solidFill>
                   <a:srgbClr val="0A2540"/>
                 </a:solidFill>
@@ -5872,7 +5872,7 @@
               <a:t>Problem Statement Title –</a:t>
             </a:r>
             <a:r>
-              <a:rPr sz="1350" b="0">
+              <a:rPr sz="1250" b="0">
                 <a:solidFill>
                   <a:srgbClr val="334155"/>
                 </a:solidFill>
@@ -5884,14 +5884,14 @@
           <a:p>
             <a:pPr>
               <a:spcBef>
-                <a:spcPts val="300"/>
+                <a:spcPts val="250"/>
               </a:spcBef>
               <a:spcAft>
-                <a:spcPts val="300"/>
+                <a:spcPts val="250"/>
               </a:spcAft>
             </a:pPr>
             <a:r>
-              <a:rPr sz="1400" b="1">
+              <a:rPr sz="1300" b="1">
                 <a:solidFill>
                   <a:srgbClr val="0A2540"/>
                 </a:solidFill>
@@ -5900,7 +5900,7 @@
               <a:t>Theme –</a:t>
             </a:r>
             <a:r>
-              <a:rPr sz="1350" b="0">
+              <a:rPr sz="1250" b="0">
                 <a:solidFill>
                   <a:srgbClr val="334155"/>
                 </a:solidFill>
@@ -5912,14 +5912,14 @@
           <a:p>
             <a:pPr>
               <a:spcBef>
-                <a:spcPts val="300"/>
+                <a:spcPts val="250"/>
               </a:spcBef>
               <a:spcAft>
-                <a:spcPts val="300"/>
+                <a:spcPts val="250"/>
               </a:spcAft>
             </a:pPr>
             <a:r>
-              <a:rPr sz="1400" b="1">
+              <a:rPr sz="1300" b="1">
                 <a:solidFill>
                   <a:srgbClr val="0A2540"/>
                 </a:solidFill>
@@ -5928,7 +5928,7 @@
               <a:t>PS Category –</a:t>
             </a:r>
             <a:r>
-              <a:rPr sz="1350" b="0">
+              <a:rPr sz="1250" b="0">
                 <a:solidFill>
                   <a:srgbClr val="334155"/>
                 </a:solidFill>
@@ -5940,14 +5940,14 @@
           <a:p>
             <a:pPr>
               <a:spcBef>
-                <a:spcPts val="300"/>
+                <a:spcPts val="250"/>
               </a:spcBef>
               <a:spcAft>
-                <a:spcPts val="300"/>
+                <a:spcPts val="250"/>
               </a:spcAft>
             </a:pPr>
             <a:r>
-              <a:rPr sz="1400" b="1">
+              <a:rPr sz="1300" b="1">
                 <a:solidFill>
                   <a:srgbClr val="0A2540"/>
                 </a:solidFill>
@@ -5956,125 +5956,125 @@
               <a:t>Team ID –</a:t>
             </a:r>
             <a:r>
-              <a:rPr sz="1350" b="0">
+              <a:rPr sz="1250" b="0">
                 <a:solidFill>
                   <a:srgbClr val="334155"/>
                 </a:solidFill>
                 <a:latin typeface="Arial"/>
               </a:rPr>
-              <a:t> [Enter Your SIH Registered Team ID]</a:t>
+              <a:t> [Enter Your Registered SIH Team ID]</a:t>
             </a:r>
           </a:p>
           <a:p>
             <a:pPr>
               <a:spcBef>
-                <a:spcPts val="300"/>
+                <a:spcPts val="250"/>
               </a:spcBef>
               <a:spcAft>
-                <a:spcPts val="300"/>
+                <a:spcPts val="250"/>
               </a:spcAft>
             </a:pPr>
             <a:r>
-              <a:rPr sz="1400" b="1">
+              <a:rPr sz="1300" b="1">
                 <a:solidFill>
                   <a:srgbClr val="0A2540"/>
                 </a:solidFill>
                 <a:latin typeface="Arial"/>
               </a:rPr>
-              <a:t>Team Name –</a:t>
-            </a:r>
-            <a:r>
-              <a:rPr sz="1350" b="0">
+              <a:t>Team Name (Registered on portal) –</a:t>
+            </a:r>
+            <a:r>
+              <a:rPr sz="1250" b="0">
                 <a:solidFill>
                   <a:srgbClr val="334155"/>
                 </a:solidFill>
                 <a:latin typeface="Arial"/>
               </a:rPr>
-              <a:t> Team GramSetu (Registered on portal)</a:t>
+              <a:t> SankalpX</a:t>
             </a:r>
           </a:p>
           <a:p>
             <a:pPr>
               <a:spcBef>
-                <a:spcPts val="300"/>
+                <a:spcPts val="250"/>
               </a:spcBef>
               <a:spcAft>
-                <a:spcPts val="300"/>
+                <a:spcPts val="250"/>
               </a:spcAft>
             </a:pPr>
             <a:r>
-              <a:rPr sz="1400" b="1">
+              <a:rPr sz="1300" b="1">
                 <a:solidFill>
                   <a:srgbClr val="0A2540"/>
                 </a:solidFill>
                 <a:latin typeface="Arial"/>
               </a:rPr>
-              <a:t>Project Name –</a:t>
-            </a:r>
-            <a:r>
-              <a:rPr sz="1350" b="0">
+              <a:t>Team Members –</a:t>
+            </a:r>
+            <a:r>
+              <a:rPr sz="1250" b="0">
                 <a:solidFill>
                   <a:srgbClr val="334155"/>
                 </a:solidFill>
                 <a:latin typeface="Arial"/>
               </a:rPr>
-              <a:t> GramSetu (ग्रामसेतू) — Rural Governance Platform</a:t>
+              <a:t> More Sanjivani, Deshmukh Anushka, Thorat Saujanya, Nehe Dhanshri, Khurud Tanushri, Dhokchaule Omsaish</a:t>
             </a:r>
           </a:p>
           <a:p>
             <a:pPr>
               <a:spcBef>
-                <a:spcPts val="300"/>
+                <a:spcPts val="250"/>
               </a:spcBef>
               <a:spcAft>
-                <a:spcPts val="300"/>
+                <a:spcPts val="250"/>
               </a:spcAft>
             </a:pPr>
             <a:r>
-              <a:rPr sz="1400" b="1">
+              <a:rPr sz="1300" b="1">
                 <a:solidFill>
                   <a:srgbClr val="0A2540"/>
                 </a:solidFill>
                 <a:latin typeface="Arial"/>
               </a:rPr>
-              <a:t>Live Working Portal –</a:t>
-            </a:r>
-            <a:r>
-              <a:rPr sz="1350" b="0">
+              <a:t>Project Name –</a:t>
+            </a:r>
+            <a:r>
+              <a:rPr sz="1250" b="0">
                 <a:solidFill>
                   <a:srgbClr val="334155"/>
                 </a:solidFill>
                 <a:latin typeface="Arial"/>
               </a:rPr>
-              <a:t> https://gramsetu-rural-governance-platform.vercel.app</a:t>
+              <a:t> GramSetu (ग्रामसेतू) — Rural Governance Platform</a:t>
             </a:r>
           </a:p>
           <a:p>
             <a:pPr>
               <a:spcBef>
-                <a:spcPts val="300"/>
+                <a:spcPts val="250"/>
               </a:spcBef>
               <a:spcAft>
-                <a:spcPts val="300"/>
+                <a:spcPts val="250"/>
               </a:spcAft>
             </a:pPr>
             <a:r>
-              <a:rPr sz="1400" b="1">
+              <a:rPr sz="1300" b="1">
                 <a:solidFill>
                   <a:srgbClr val="0A2540"/>
                 </a:solidFill>
                 <a:latin typeface="Arial"/>
               </a:rPr>
-              <a:t>Live Backend API –</a:t>
-            </a:r>
-            <a:r>
-              <a:rPr sz="1350" b="0">
+              <a:t>Live Working Prototype –</a:t>
+            </a:r>
+            <a:r>
+              <a:rPr sz="1250" b="0">
                 <a:solidFill>
                   <a:srgbClr val="334155"/>
                 </a:solidFill>
                 <a:latin typeface="Arial"/>
               </a:rPr>
-              <a:t> https://gramsetu-rural-governance-platform.onrender.com</a:t>
+              <a:t> https://gramsetu-rural-governance-platform.vercel.app  (API: https://gramsetu-rural-governance-platform.onrender.com)</a:t>
             </a:r>
           </a:p>
         </p:txBody>
@@ -6689,7 +6689,7 @@
           <a:p>
             <a:pPr algn="ctr"/>
             <a:r>
-              <a:rPr sz="950" b="1">
+              <a:rPr sz="1050" b="1">
                 <a:solidFill>
                   <a:srgbClr val="FFFFFF"/>
                 </a:solidFill>
@@ -7361,7 +7361,7 @@
           <a:p>
             <a:pPr algn="ctr"/>
             <a:r>
-              <a:rPr sz="950" b="1">
+              <a:rPr sz="1050" b="1">
                 <a:solidFill>
                   <a:srgbClr val="FFFFFF"/>
                 </a:solidFill>
@@ -8152,7 +8152,7 @@
           <a:p>
             <a:pPr algn="ctr"/>
             <a:r>
-              <a:rPr sz="950" b="1">
+              <a:rPr sz="1050" b="1">
                 <a:solidFill>
                   <a:srgbClr val="FFFFFF"/>
                 </a:solidFill>
@@ -8850,7 +8850,7 @@
           <a:p>
             <a:pPr algn="ctr"/>
             <a:r>
-              <a:rPr sz="950" b="1">
+              <a:rPr sz="1050" b="1">
                 <a:solidFill>
                   <a:srgbClr val="FFFFFF"/>
                 </a:solidFill>
@@ -9674,7 +9674,7 @@
           <a:p>
             <a:pPr algn="ctr"/>
             <a:r>
-              <a:rPr sz="950" b="1">
+              <a:rPr sz="1050" b="1">
                 <a:solidFill>
                   <a:srgbClr val="FFFFFF"/>
                 </a:solidFill>

</xml_diff>